<commit_message>
all-slides-with-answers.pdf all-slides.pdf classes.pdf classes.pptx lambda.pdf lambda.pptx
</commit_message>
<xml_diff>
--- a/ipsa/slides/lambda.pptx
+++ b/ipsa/slides/lambda.pptx
@@ -135,23 +135,46 @@
 </p:presentation>
 </file>
 
-<file path=ppt/revisionInfo.xml><?xml version="1.0" encoding="utf-8"?>
-<p1510:revInfo xmlns:a="http://schemas.openxmlformats.org/drawingml/2006/main" xmlns:r="http://schemas.openxmlformats.org/officeDocument/2006/relationships" xmlns:p1510="http://schemas.microsoft.com/office/powerpoint/2015/10/main">
-  <p1510:revLst>
-    <p1510:client id="{546A4144-B64D-4C3F-BBEA-9267EAB3C81C}" v="8" dt="2026-02-19T22:14:40.753"/>
-  </p1510:revLst>
-</p1510:revInfo>
-</file>
-
 <file path=ppt/changesInfos/changesInfo1.xml><?xml version="1.0" encoding="utf-8"?>
 <pc:chgInfo xmlns:a="http://schemas.openxmlformats.org/drawingml/2006/main" xmlns:r="http://schemas.openxmlformats.org/officeDocument/2006/relationships" xmlns:ac="http://schemas.microsoft.com/office/drawing/2013/main/command" xmlns:pc="http://schemas.microsoft.com/office/powerpoint/2013/main/command">
   <pc:docChgLst>
     <pc:chgData name="Gerth Stølting Brodal" userId="04ef4784-6591-4f86-a140-f5c3b108582a" providerId="ADAL" clId="{73BAC7D6-516A-44B5-B4B0-C7B08CA8B392}"/>
     <pc:docChg chg="undo custSel modSld">
-      <pc:chgData name="Gerth Stølting Brodal" userId="04ef4784-6591-4f86-a140-f5c3b108582a" providerId="ADAL" clId="{73BAC7D6-516A-44B5-B4B0-C7B08CA8B392}" dt="2026-02-19T22:16:26.747" v="362" actId="1036"/>
+      <pc:chgData name="Gerth Stølting Brodal" userId="04ef4784-6591-4f86-a140-f5c3b108582a" providerId="ADAL" clId="{73BAC7D6-516A-44B5-B4B0-C7B08CA8B392}" dt="2026-03-02T05:55:22.769" v="363" actId="790"/>
       <pc:docMkLst>
         <pc:docMk/>
       </pc:docMkLst>
+      <pc:sldChg chg="modSp mod">
+        <pc:chgData name="Gerth Stølting Brodal" userId="04ef4784-6591-4f86-a140-f5c3b108582a" providerId="ADAL" clId="{73BAC7D6-516A-44B5-B4B0-C7B08CA8B392}" dt="2026-03-02T05:55:22.769" v="363" actId="790"/>
+        <pc:sldMkLst>
+          <pc:docMk/>
+          <pc:sldMk cId="2553496854" sldId="614"/>
+        </pc:sldMkLst>
+        <pc:spChg chg="mod">
+          <ac:chgData name="Gerth Stølting Brodal" userId="04ef4784-6591-4f86-a140-f5c3b108582a" providerId="ADAL" clId="{73BAC7D6-516A-44B5-B4B0-C7B08CA8B392}" dt="2026-03-02T05:55:22.769" v="363" actId="790"/>
+          <ac:spMkLst>
+            <pc:docMk/>
+            <pc:sldMk cId="2553496854" sldId="614"/>
+            <ac:spMk id="2" creationId="{00000000-0000-0000-0000-000000000000}"/>
+          </ac:spMkLst>
+        </pc:spChg>
+        <pc:spChg chg="mod">
+          <ac:chgData name="Gerth Stølting Brodal" userId="04ef4784-6591-4f86-a140-f5c3b108582a" providerId="ADAL" clId="{73BAC7D6-516A-44B5-B4B0-C7B08CA8B392}" dt="2026-03-02T05:55:22.769" v="363" actId="790"/>
+          <ac:spMkLst>
+            <pc:docMk/>
+            <pc:sldMk cId="2553496854" sldId="614"/>
+            <ac:spMk id="5" creationId="{00000000-0000-0000-0000-000000000000}"/>
+          </ac:spMkLst>
+        </pc:spChg>
+        <pc:graphicFrameChg chg="modGraphic">
+          <ac:chgData name="Gerth Stølting Brodal" userId="04ef4784-6591-4f86-a140-f5c3b108582a" providerId="ADAL" clId="{73BAC7D6-516A-44B5-B4B0-C7B08CA8B392}" dt="2026-03-02T05:55:22.769" v="363" actId="790"/>
+          <ac:graphicFrameMkLst>
+            <pc:docMk/>
+            <pc:sldMk cId="2553496854" sldId="614"/>
+            <ac:graphicFrameMk id="4" creationId="{00000000-0000-0000-0000-000000000000}"/>
+          </ac:graphicFrameMkLst>
+        </pc:graphicFrameChg>
+      </pc:sldChg>
       <pc:sldChg chg="modSp mod">
         <pc:chgData name="Gerth Stølting Brodal" userId="04ef4784-6591-4f86-a140-f5c3b108582a" providerId="ADAL" clId="{73BAC7D6-516A-44B5-B4B0-C7B08CA8B392}" dt="2026-02-19T21:36:18.114" v="73" actId="20577"/>
         <pc:sldMkLst>
@@ -269,7 +292,7 @@
           <a:p>
             <a:fld id="{FB1A172F-81D4-4DC4-9113-1DBD56EC3646}" type="datetimeFigureOut">
               <a:rPr lang="en-US" smtClean="0"/>
-              <a:t>2/19/2026</a:t>
+              <a:t>3/2/2026</a:t>
             </a:fld>
             <a:endParaRPr lang="en-US"/>
           </a:p>
@@ -2485,7 +2508,7 @@
           <a:p>
             <a:fld id="{0560A9CD-0304-4E0B-9E82-E7E0115DE05B}" type="datetimeFigureOut">
               <a:rPr lang="en-US" smtClean="0"/>
-              <a:t>2/19/2026</a:t>
+              <a:t>3/2/2026</a:t>
             </a:fld>
             <a:endParaRPr lang="en-US"/>
           </a:p>
@@ -2653,7 +2676,7 @@
           <a:p>
             <a:fld id="{0560A9CD-0304-4E0B-9E82-E7E0115DE05B}" type="datetimeFigureOut">
               <a:rPr lang="en-US" smtClean="0"/>
-              <a:t>2/19/2026</a:t>
+              <a:t>3/2/2026</a:t>
             </a:fld>
             <a:endParaRPr lang="en-US"/>
           </a:p>
@@ -2831,7 +2854,7 @@
           <a:p>
             <a:fld id="{0560A9CD-0304-4E0B-9E82-E7E0115DE05B}" type="datetimeFigureOut">
               <a:rPr lang="en-US" smtClean="0"/>
-              <a:t>2/19/2026</a:t>
+              <a:t>3/2/2026</a:t>
             </a:fld>
             <a:endParaRPr lang="en-US"/>
           </a:p>
@@ -3014,7 +3037,7 @@
           <a:p>
             <a:fld id="{0560A9CD-0304-4E0B-9E82-E7E0115DE05B}" type="datetimeFigureOut">
               <a:rPr lang="en-US" smtClean="0"/>
-              <a:t>2/19/2026</a:t>
+              <a:t>3/2/2026</a:t>
             </a:fld>
             <a:endParaRPr lang="en-US"/>
           </a:p>
@@ -3259,7 +3282,7 @@
           <a:p>
             <a:fld id="{0560A9CD-0304-4E0B-9E82-E7E0115DE05B}" type="datetimeFigureOut">
               <a:rPr lang="en-US" smtClean="0"/>
-              <a:t>2/19/2026</a:t>
+              <a:t>3/2/2026</a:t>
             </a:fld>
             <a:endParaRPr lang="en-US"/>
           </a:p>
@@ -3488,7 +3511,7 @@
           <a:p>
             <a:fld id="{0560A9CD-0304-4E0B-9E82-E7E0115DE05B}" type="datetimeFigureOut">
               <a:rPr lang="en-US" smtClean="0"/>
-              <a:t>2/19/2026</a:t>
+              <a:t>3/2/2026</a:t>
             </a:fld>
             <a:endParaRPr lang="en-US"/>
           </a:p>
@@ -3852,7 +3875,7 @@
           <a:p>
             <a:fld id="{0560A9CD-0304-4E0B-9E82-E7E0115DE05B}" type="datetimeFigureOut">
               <a:rPr lang="en-US" smtClean="0"/>
-              <a:t>2/19/2026</a:t>
+              <a:t>3/2/2026</a:t>
             </a:fld>
             <a:endParaRPr lang="en-US"/>
           </a:p>
@@ -3969,7 +3992,7 @@
           <a:p>
             <a:fld id="{0560A9CD-0304-4E0B-9E82-E7E0115DE05B}" type="datetimeFigureOut">
               <a:rPr lang="en-US" smtClean="0"/>
-              <a:t>2/19/2026</a:t>
+              <a:t>3/2/2026</a:t>
             </a:fld>
             <a:endParaRPr lang="en-US"/>
           </a:p>
@@ -4064,7 +4087,7 @@
           <a:p>
             <a:fld id="{0560A9CD-0304-4E0B-9E82-E7E0115DE05B}" type="datetimeFigureOut">
               <a:rPr lang="en-US" smtClean="0"/>
-              <a:t>2/19/2026</a:t>
+              <a:t>3/2/2026</a:t>
             </a:fld>
             <a:endParaRPr lang="en-US"/>
           </a:p>
@@ -4339,7 +4362,7 @@
           <a:p>
             <a:fld id="{0560A9CD-0304-4E0B-9E82-E7E0115DE05B}" type="datetimeFigureOut">
               <a:rPr lang="en-US" smtClean="0"/>
-              <a:t>2/19/2026</a:t>
+              <a:t>3/2/2026</a:t>
             </a:fld>
             <a:endParaRPr lang="en-US"/>
           </a:p>
@@ -4591,7 +4614,7 @@
           <a:p>
             <a:fld id="{0560A9CD-0304-4E0B-9E82-E7E0115DE05B}" type="datetimeFigureOut">
               <a:rPr lang="en-US" smtClean="0"/>
-              <a:t>2/19/2026</a:t>
+              <a:t>3/2/2026</a:t>
             </a:fld>
             <a:endParaRPr lang="en-US"/>
           </a:p>
@@ -4802,7 +4825,7 @@
           <a:p>
             <a:fld id="{0560A9CD-0304-4E0B-9E82-E7E0115DE05B}" type="datetimeFigureOut">
               <a:rPr lang="en-US" smtClean="0"/>
-              <a:t>2/19/2026</a:t>
+              <a:t>3/2/2026</a:t>
             </a:fld>
             <a:endParaRPr lang="en-US"/>
           </a:p>
@@ -14406,22 +14429,9 @@
           <a:p>
             <a:pPr algn="ctr"/>
             <a:r>
-              <a:rPr lang="da-DK" dirty="0"/>
-              <a:t>A </a:t>
-            </a:r>
-            <a:r>
-              <a:rPr lang="da-DK" dirty="0" err="1"/>
-              <a:t>compact</a:t>
-            </a:r>
-            <a:r>
-              <a:rPr lang="da-DK" dirty="0"/>
-              <a:t> triplet distance </a:t>
-            </a:r>
-            <a:r>
-              <a:rPr lang="da-DK" dirty="0" err="1"/>
-              <a:t>implementation</a:t>
-            </a:r>
-            <a:endParaRPr lang="en-US" dirty="0"/>
+              <a:rPr lang="en-US" noProof="0" dirty="0"/>
+              <a:t>A compact triplet distance implementation</a:t>
+            </a:r>
           </a:p>
         </p:txBody>
       </p:sp>
@@ -14434,7 +14444,7 @@
           <p:nvPr>
             <p:extLst>
               <p:ext uri="{D42A27DB-BD31-4B8C-83A1-F6EECF244321}">
-                <p14:modId xmlns:p14="http://schemas.microsoft.com/office/powerpoint/2010/main" val="1531812639"/>
+                <p14:modId xmlns:p14="http://schemas.microsoft.com/office/powerpoint/2010/main" val="4036948781"/>
               </p:ext>
             </p:extLst>
           </p:nvPr>
@@ -14465,7 +14475,7 @@
                     <a:lstStyle/>
                     <a:p>
                       <a:r>
-                        <a:rPr lang="da-DK" sz="1600" b="1" dirty="0">
+                        <a:rPr lang="en-US" sz="1600" b="1" noProof="0" dirty="0">
                           <a:latin typeface="Courier New" panose="02070309020205020404" pitchFamily="49" charset="0"/>
                           <a:cs typeface="Courier New" panose="02070309020205020404" pitchFamily="49" charset="0"/>
                         </a:rPr>
@@ -14536,14 +14546,14 @@
                     <a:lstStyle/>
                     <a:p>
                       <a:r>
-                        <a:rPr lang="pt-BR" sz="1600" b="1" dirty="0">
+                        <a:rPr lang="en-US" sz="1600" b="1" noProof="0" dirty="0">
                           <a:latin typeface="Courier New" panose="02070309020205020404" pitchFamily="49" charset="0"/>
                           <a:cs typeface="Courier New" panose="02070309020205020404" pitchFamily="49" charset="0"/>
                         </a:rPr>
                         <a:t>def </a:t>
                       </a:r>
                       <a:r>
-                        <a:rPr lang="pt-BR" sz="1600" b="1" dirty="0">
+                        <a:rPr lang="en-US" sz="1600" b="1" noProof="0" dirty="0" err="1">
                           <a:solidFill>
                             <a:srgbClr val="C00000"/>
                           </a:solidFill>
@@ -14553,7 +14563,7 @@
                         <a:t>triplet_distance</a:t>
                       </a:r>
                       <a:r>
-                        <a:rPr lang="pt-BR" sz="1600" b="1" dirty="0">
+                        <a:rPr lang="en-US" sz="1600" b="1" noProof="0" dirty="0">
                           <a:latin typeface="Courier New" panose="02070309020205020404" pitchFamily="49" charset="0"/>
                           <a:cs typeface="Courier New" panose="02070309020205020404" pitchFamily="49" charset="0"/>
                         </a:rPr>
@@ -14562,14 +14572,14 @@
                     </a:p>
                     <a:p>
                       <a:r>
-                        <a:rPr lang="pt-BR" sz="1600" b="1" dirty="0">
+                        <a:rPr lang="en-US" sz="1600" b="1" noProof="0" dirty="0">
                           <a:latin typeface="Courier New" panose="02070309020205020404" pitchFamily="49" charset="0"/>
                           <a:cs typeface="Courier New" panose="02070309020205020404" pitchFamily="49" charset="0"/>
                         </a:rPr>
                         <a:t>    def </a:t>
                       </a:r>
                       <a:r>
-                        <a:rPr lang="pt-BR" sz="1600" b="1" dirty="0">
+                        <a:rPr lang="en-US" sz="1600" b="1" noProof="0" dirty="0">
                           <a:solidFill>
                             <a:schemeClr val="accent1">
                               <a:lumMod val="50000"/>
@@ -14581,7 +14591,7 @@
                         <a:t>compute</a:t>
                       </a:r>
                       <a:r>
-                        <a:rPr lang="pt-BR" sz="1600" b="1" dirty="0">
+                        <a:rPr lang="en-US" sz="1600" b="1" noProof="0" dirty="0">
                           <a:latin typeface="Courier New" panose="02070309020205020404" pitchFamily="49" charset="0"/>
                           <a:cs typeface="Courier New" panose="02070309020205020404" pitchFamily="49" charset="0"/>
                         </a:rPr>
@@ -14590,16 +14600,30 @@
                     </a:p>
                     <a:p>
                       <a:r>
-                        <a:rPr lang="pt-BR" sz="1600" b="1" dirty="0">
-                          <a:latin typeface="Courier New" panose="02070309020205020404" pitchFamily="49" charset="0"/>
-                          <a:cs typeface="Courier New" panose="02070309020205020404" pitchFamily="49" charset="0"/>
-                        </a:rPr>
-                        <a:t>        if not isinstance(tree, tuple): </a:t>
-                      </a:r>
-                    </a:p>
-                    <a:p>
-                      <a:r>
-                        <a:rPr lang="pt-BR" sz="1600" b="1" dirty="0">
+                        <a:rPr lang="en-US" sz="1600" b="1" noProof="0" dirty="0">
+                          <a:latin typeface="Courier New" panose="02070309020205020404" pitchFamily="49" charset="0"/>
+                          <a:cs typeface="Courier New" panose="02070309020205020404" pitchFamily="49" charset="0"/>
+                        </a:rPr>
+                        <a:t>        if not </a:t>
+                      </a:r>
+                      <a:r>
+                        <a:rPr lang="en-US" sz="1600" b="1" noProof="0" dirty="0" err="1">
+                          <a:latin typeface="Courier New" panose="02070309020205020404" pitchFamily="49" charset="0"/>
+                          <a:cs typeface="Courier New" panose="02070309020205020404" pitchFamily="49" charset="0"/>
+                        </a:rPr>
+                        <a:t>isinstance</a:t>
+                      </a:r>
+                      <a:r>
+                        <a:rPr lang="en-US" sz="1600" b="1" noProof="0" dirty="0">
+                          <a:latin typeface="Courier New" panose="02070309020205020404" pitchFamily="49" charset="0"/>
+                          <a:cs typeface="Courier New" panose="02070309020205020404" pitchFamily="49" charset="0"/>
+                        </a:rPr>
+                        <a:t>(tree, tuple): </a:t>
+                      </a:r>
+                    </a:p>
+                    <a:p>
+                      <a:r>
+                        <a:rPr lang="en-US" sz="1600" b="1" noProof="0" dirty="0">
                           <a:latin typeface="Courier New" panose="02070309020205020404" pitchFamily="49" charset="0"/>
                           <a:cs typeface="Courier New" panose="02070309020205020404" pitchFamily="49" charset="0"/>
                         </a:rPr>
@@ -14608,14 +14632,56 @@
                     </a:p>
                     <a:p>
                       <a:r>
-                        <a:rPr lang="pt-BR" sz="1600" b="1" dirty="0">
-                          <a:latin typeface="Courier New" panose="02070309020205020404" pitchFamily="49" charset="0"/>
-                          <a:cs typeface="Courier New" panose="02070309020205020404" pitchFamily="49" charset="0"/>
-                        </a:rPr>
-                        <a:t>        (ll, lt), (rl, rt) = [</a:t>
-                      </a:r>
-                      <a:r>
-                        <a:rPr lang="pt-BR" sz="1600" b="1" dirty="0">
+                        <a:rPr lang="en-US" sz="1600" b="1" noProof="0" dirty="0">
+                          <a:latin typeface="Courier New" panose="02070309020205020404" pitchFamily="49" charset="0"/>
+                          <a:cs typeface="Courier New" panose="02070309020205020404" pitchFamily="49" charset="0"/>
+                        </a:rPr>
+                        <a:t>        (</a:t>
+                      </a:r>
+                      <a:r>
+                        <a:rPr lang="en-US" sz="1600" b="1" noProof="0" dirty="0" err="1">
+                          <a:latin typeface="Courier New" panose="02070309020205020404" pitchFamily="49" charset="0"/>
+                          <a:cs typeface="Courier New" panose="02070309020205020404" pitchFamily="49" charset="0"/>
+                        </a:rPr>
+                        <a:t>ll</a:t>
+                      </a:r>
+                      <a:r>
+                        <a:rPr lang="en-US" sz="1600" b="1" noProof="0" dirty="0">
+                          <a:latin typeface="Courier New" panose="02070309020205020404" pitchFamily="49" charset="0"/>
+                          <a:cs typeface="Courier New" panose="02070309020205020404" pitchFamily="49" charset="0"/>
+                        </a:rPr>
+                        <a:t>, </a:t>
+                      </a:r>
+                      <a:r>
+                        <a:rPr lang="en-US" sz="1600" b="1" noProof="0" dirty="0" err="1">
+                          <a:latin typeface="Courier New" panose="02070309020205020404" pitchFamily="49" charset="0"/>
+                          <a:cs typeface="Courier New" panose="02070309020205020404" pitchFamily="49" charset="0"/>
+                        </a:rPr>
+                        <a:t>lt</a:t>
+                      </a:r>
+                      <a:r>
+                        <a:rPr lang="en-US" sz="1600" b="1" noProof="0" dirty="0">
+                          <a:latin typeface="Courier New" panose="02070309020205020404" pitchFamily="49" charset="0"/>
+                          <a:cs typeface="Courier New" panose="02070309020205020404" pitchFamily="49" charset="0"/>
+                        </a:rPr>
+                        <a:t>), (</a:t>
+                      </a:r>
+                      <a:r>
+                        <a:rPr lang="en-US" sz="1600" b="1" noProof="0" dirty="0" err="1">
+                          <a:latin typeface="Courier New" panose="02070309020205020404" pitchFamily="49" charset="0"/>
+                          <a:cs typeface="Courier New" panose="02070309020205020404" pitchFamily="49" charset="0"/>
+                        </a:rPr>
+                        <a:t>rl</a:t>
+                      </a:r>
+                      <a:r>
+                        <a:rPr lang="en-US" sz="1600" b="1" noProof="0" dirty="0">
+                          <a:latin typeface="Courier New" panose="02070309020205020404" pitchFamily="49" charset="0"/>
+                          <a:cs typeface="Courier New" panose="02070309020205020404" pitchFamily="49" charset="0"/>
+                        </a:rPr>
+                        <a:t>, rt) = [</a:t>
+                      </a:r>
+                      <a:r>
+                        <a:rPr lang="en-US" sz="1600" b="1" noProof="0" dirty="0">
                           <a:solidFill>
                             <a:schemeClr val="accent1">
                               <a:lumMod val="50000"/>
@@ -14627,7 +14693,7 @@
                         <a:t>compute</a:t>
                       </a:r>
                       <a:r>
-                        <a:rPr lang="pt-BR" sz="1600" b="1" dirty="0">
+                        <a:rPr lang="en-US" sz="1600" b="1" noProof="0" dirty="0">
                           <a:latin typeface="Courier New" panose="02070309020205020404" pitchFamily="49" charset="0"/>
                           <a:cs typeface="Courier New" panose="02070309020205020404" pitchFamily="49" charset="0"/>
                         </a:rPr>
@@ -14636,38 +14702,136 @@
                     </a:p>
                     <a:p>
                       <a:r>
-                        <a:rPr lang="pt-BR" sz="1600" b="1" dirty="0">
-                          <a:latin typeface="Courier New" panose="02070309020205020404" pitchFamily="49" charset="0"/>
-                          <a:cs typeface="Courier New" panose="02070309020205020404" pitchFamily="49" charset="0"/>
-                        </a:rPr>
-                        <a:t>        t = [(x,(y,z)) for a,b in [(ll,rl), (rl,ll)] for y in b for z in b if y &lt; z for x in a]</a:t>
-                      </a:r>
-                    </a:p>
-                    <a:p>
-                      <a:r>
-                        <a:rPr lang="pt-BR" sz="1600" b="1" dirty="0">
-                          <a:latin typeface="Courier New" panose="02070309020205020404" pitchFamily="49" charset="0"/>
-                          <a:cs typeface="Courier New" panose="02070309020205020404" pitchFamily="49" charset="0"/>
-                        </a:rPr>
-                        <a:t>        return ll + rl, lt + rt + t</a:t>
-                      </a:r>
-                    </a:p>
-                    <a:p>
-                      <a:endParaRPr lang="pt-BR" sz="1600" b="1" dirty="0">
+                        <a:rPr lang="en-US" sz="1600" b="1" noProof="0" dirty="0">
+                          <a:latin typeface="Courier New" panose="02070309020205020404" pitchFamily="49" charset="0"/>
+                          <a:cs typeface="Courier New" panose="02070309020205020404" pitchFamily="49" charset="0"/>
+                        </a:rPr>
+                        <a:t>        t = [(x,(</a:t>
+                      </a:r>
+                      <a:r>
+                        <a:rPr lang="en-US" sz="1600" b="1" noProof="0" dirty="0" err="1">
+                          <a:latin typeface="Courier New" panose="02070309020205020404" pitchFamily="49" charset="0"/>
+                          <a:cs typeface="Courier New" panose="02070309020205020404" pitchFamily="49" charset="0"/>
+                        </a:rPr>
+                        <a:t>y,z</a:t>
+                      </a:r>
+                      <a:r>
+                        <a:rPr lang="en-US" sz="1600" b="1" noProof="0" dirty="0">
+                          <a:latin typeface="Courier New" panose="02070309020205020404" pitchFamily="49" charset="0"/>
+                          <a:cs typeface="Courier New" panose="02070309020205020404" pitchFamily="49" charset="0"/>
+                        </a:rPr>
+                        <a:t>)) for </a:t>
+                      </a:r>
+                      <a:r>
+                        <a:rPr lang="en-US" sz="1600" b="1" noProof="0" dirty="0" err="1">
+                          <a:latin typeface="Courier New" panose="02070309020205020404" pitchFamily="49" charset="0"/>
+                          <a:cs typeface="Courier New" panose="02070309020205020404" pitchFamily="49" charset="0"/>
+                        </a:rPr>
+                        <a:t>a,b</a:t>
+                      </a:r>
+                      <a:r>
+                        <a:rPr lang="en-US" sz="1600" b="1" noProof="0" dirty="0">
+                          <a:latin typeface="Courier New" panose="02070309020205020404" pitchFamily="49" charset="0"/>
+                          <a:cs typeface="Courier New" panose="02070309020205020404" pitchFamily="49" charset="0"/>
+                        </a:rPr>
+                        <a:t> in [(</a:t>
+                      </a:r>
+                      <a:r>
+                        <a:rPr lang="en-US" sz="1600" b="1" noProof="0" dirty="0" err="1">
+                          <a:latin typeface="Courier New" panose="02070309020205020404" pitchFamily="49" charset="0"/>
+                          <a:cs typeface="Courier New" panose="02070309020205020404" pitchFamily="49" charset="0"/>
+                        </a:rPr>
+                        <a:t>ll,rl</a:t>
+                      </a:r>
+                      <a:r>
+                        <a:rPr lang="en-US" sz="1600" b="1" noProof="0" dirty="0">
+                          <a:latin typeface="Courier New" panose="02070309020205020404" pitchFamily="49" charset="0"/>
+                          <a:cs typeface="Courier New" panose="02070309020205020404" pitchFamily="49" charset="0"/>
+                        </a:rPr>
+                        <a:t>), (</a:t>
+                      </a:r>
+                      <a:r>
+                        <a:rPr lang="en-US" sz="1600" b="1" noProof="0" dirty="0" err="1">
+                          <a:latin typeface="Courier New" panose="02070309020205020404" pitchFamily="49" charset="0"/>
+                          <a:cs typeface="Courier New" panose="02070309020205020404" pitchFamily="49" charset="0"/>
+                        </a:rPr>
+                        <a:t>rl,ll</a:t>
+                      </a:r>
+                      <a:r>
+                        <a:rPr lang="en-US" sz="1600" b="1" noProof="0" dirty="0">
+                          <a:latin typeface="Courier New" panose="02070309020205020404" pitchFamily="49" charset="0"/>
+                          <a:cs typeface="Courier New" panose="02070309020205020404" pitchFamily="49" charset="0"/>
+                        </a:rPr>
+                        <a:t>)] for y in b for z in b if y &lt; z for x in a]</a:t>
+                      </a:r>
+                    </a:p>
+                    <a:p>
+                      <a:r>
+                        <a:rPr lang="en-US" sz="1600" b="1" noProof="0" dirty="0">
+                          <a:latin typeface="Courier New" panose="02070309020205020404" pitchFamily="49" charset="0"/>
+                          <a:cs typeface="Courier New" panose="02070309020205020404" pitchFamily="49" charset="0"/>
+                        </a:rPr>
+                        <a:t>        return </a:t>
+                      </a:r>
+                      <a:r>
+                        <a:rPr lang="en-US" sz="1600" b="1" noProof="0" dirty="0" err="1">
+                          <a:latin typeface="Courier New" panose="02070309020205020404" pitchFamily="49" charset="0"/>
+                          <a:cs typeface="Courier New" panose="02070309020205020404" pitchFamily="49" charset="0"/>
+                        </a:rPr>
+                        <a:t>ll</a:t>
+                      </a:r>
+                      <a:r>
+                        <a:rPr lang="en-US" sz="1600" b="1" noProof="0" dirty="0">
+                          <a:latin typeface="Courier New" panose="02070309020205020404" pitchFamily="49" charset="0"/>
+                          <a:cs typeface="Courier New" panose="02070309020205020404" pitchFamily="49" charset="0"/>
+                        </a:rPr>
+                        <a:t> + </a:t>
+                      </a:r>
+                      <a:r>
+                        <a:rPr lang="en-US" sz="1600" b="1" noProof="0" dirty="0" err="1">
+                          <a:latin typeface="Courier New" panose="02070309020205020404" pitchFamily="49" charset="0"/>
+                          <a:cs typeface="Courier New" panose="02070309020205020404" pitchFamily="49" charset="0"/>
+                        </a:rPr>
+                        <a:t>rl</a:t>
+                      </a:r>
+                      <a:r>
+                        <a:rPr lang="en-US" sz="1600" b="1" noProof="0" dirty="0">
+                          <a:latin typeface="Courier New" panose="02070309020205020404" pitchFamily="49" charset="0"/>
+                          <a:cs typeface="Courier New" panose="02070309020205020404" pitchFamily="49" charset="0"/>
+                        </a:rPr>
+                        <a:t>, </a:t>
+                      </a:r>
+                      <a:r>
+                        <a:rPr lang="en-US" sz="1600" b="1" noProof="0" dirty="0" err="1">
+                          <a:latin typeface="Courier New" panose="02070309020205020404" pitchFamily="49" charset="0"/>
+                          <a:cs typeface="Courier New" panose="02070309020205020404" pitchFamily="49" charset="0"/>
+                        </a:rPr>
+                        <a:t>lt</a:t>
+                      </a:r>
+                      <a:r>
+                        <a:rPr lang="en-US" sz="1600" b="1" noProof="0" dirty="0">
+                          <a:latin typeface="Courier New" panose="02070309020205020404" pitchFamily="49" charset="0"/>
+                          <a:cs typeface="Courier New" panose="02070309020205020404" pitchFamily="49" charset="0"/>
+                        </a:rPr>
+                        <a:t> + rt + t</a:t>
+                      </a:r>
+                    </a:p>
+                    <a:p>
+                      <a:endParaRPr lang="en-US" sz="1600" b="1" noProof="0" dirty="0">
                         <a:latin typeface="Courier New" panose="02070309020205020404" pitchFamily="49" charset="0"/>
                         <a:cs typeface="Courier New" panose="02070309020205020404" pitchFamily="49" charset="0"/>
                       </a:endParaRPr>
                     </a:p>
                     <a:p>
                       <a:r>
-                        <a:rPr lang="pt-BR" sz="1600" b="1" dirty="0">
+                        <a:rPr lang="en-US" sz="1600" b="1" noProof="0" dirty="0">
                           <a:latin typeface="Courier New" panose="02070309020205020404" pitchFamily="49" charset="0"/>
                           <a:cs typeface="Courier New" panose="02070309020205020404" pitchFamily="49" charset="0"/>
                         </a:rPr>
                         <a:t>    (L1, T1), (L2, T2) = </a:t>
                       </a:r>
                       <a:r>
-                        <a:rPr lang="pt-BR" sz="1600" b="1" dirty="0">
+                        <a:rPr lang="en-US" sz="1600" b="1" noProof="0" dirty="0">
                           <a:solidFill>
                             <a:schemeClr val="accent1">
                               <a:lumMod val="50000"/>
@@ -14679,14 +14843,14 @@
                         <a:t>compute</a:t>
                       </a:r>
                       <a:r>
-                        <a:rPr lang="pt-BR" sz="1600" b="1" dirty="0">
+                        <a:rPr lang="en-US" sz="1600" b="1" noProof="0" dirty="0">
                           <a:latin typeface="Courier New" panose="02070309020205020404" pitchFamily="49" charset="0"/>
                           <a:cs typeface="Courier New" panose="02070309020205020404" pitchFamily="49" charset="0"/>
                         </a:rPr>
                         <a:t>(tree1), </a:t>
                       </a:r>
                       <a:r>
-                        <a:rPr lang="pt-BR" sz="1600" b="1" dirty="0">
+                        <a:rPr lang="en-US" sz="1600" b="1" noProof="0" dirty="0">
                           <a:solidFill>
                             <a:schemeClr val="accent1">
                               <a:lumMod val="50000"/>
@@ -14698,7 +14862,7 @@
                         <a:t>compute</a:t>
                       </a:r>
                       <a:r>
-                        <a:rPr lang="pt-BR" sz="1600" b="1" dirty="0">
+                        <a:rPr lang="en-US" sz="1600" b="1" noProof="0" dirty="0">
                           <a:latin typeface="Courier New" panose="02070309020205020404" pitchFamily="49" charset="0"/>
                           <a:cs typeface="Courier New" panose="02070309020205020404" pitchFamily="49" charset="0"/>
                         </a:rPr>
@@ -14707,16 +14871,26 @@
                     </a:p>
                     <a:p>
                       <a:r>
-                        <a:rPr lang="pt-BR" sz="1600" b="1" dirty="0">
-                          <a:latin typeface="Courier New" panose="02070309020205020404" pitchFamily="49" charset="0"/>
-                          <a:cs typeface="Courier New" panose="02070309020205020404" pitchFamily="49" charset="0"/>
-                        </a:rPr>
-                        <a:t>    return len(set(T1) - set(T2))</a:t>
-                      </a:r>
-                      <a:endParaRPr lang="da-DK" sz="1600" b="1" dirty="0">
-                        <a:latin typeface="Courier New" panose="02070309020205020404" pitchFamily="49" charset="0"/>
-                        <a:cs typeface="Courier New" panose="02070309020205020404" pitchFamily="49" charset="0"/>
-                      </a:endParaRPr>
+                        <a:rPr lang="en-US" sz="1600" b="1" noProof="0" dirty="0">
+                          <a:latin typeface="Courier New" panose="02070309020205020404" pitchFamily="49" charset="0"/>
+                          <a:cs typeface="Courier New" panose="02070309020205020404" pitchFamily="49" charset="0"/>
+                        </a:rPr>
+                        <a:t>    return </a:t>
+                      </a:r>
+                      <a:r>
+                        <a:rPr lang="en-US" sz="1600" b="1" noProof="0" dirty="0" err="1">
+                          <a:latin typeface="Courier New" panose="02070309020205020404" pitchFamily="49" charset="0"/>
+                          <a:cs typeface="Courier New" panose="02070309020205020404" pitchFamily="49" charset="0"/>
+                        </a:rPr>
+                        <a:t>len</a:t>
+                      </a:r>
+                      <a:r>
+                        <a:rPr lang="en-US" sz="1600" b="1" noProof="0" dirty="0">
+                          <a:latin typeface="Courier New" panose="02070309020205020404" pitchFamily="49" charset="0"/>
+                          <a:cs typeface="Courier New" panose="02070309020205020404" pitchFamily="49" charset="0"/>
+                        </a:rPr>
+                        <a:t>(set(T1) - set(T2))</a:t>
+                      </a:r>
                     </a:p>
                   </a:txBody>
                   <a:tcPr>
@@ -14806,7 +14980,7 @@
           <a:p>
             <a:pPr algn="ctr"/>
             <a:r>
-              <a:rPr lang="da-DK" dirty="0">
+              <a:rPr lang="en-US" noProof="0" dirty="0">
                 <a:solidFill>
                   <a:srgbClr val="C00000"/>
                 </a:solidFill>
@@ -14814,97 +14988,17 @@
               <a:t>Warning </a:t>
             </a:r>
             <a:r>
-              <a:rPr lang="da-DK" dirty="0">
+              <a:rPr lang="en-US" noProof="0" dirty="0">
                 <a:solidFill>
                   <a:schemeClr val="bg1">
                     <a:lumMod val="50000"/>
                   </a:schemeClr>
                 </a:solidFill>
               </a:rPr>
-              <a:t> Do not </a:t>
-            </a:r>
-            <a:r>
-              <a:rPr lang="da-DK" dirty="0" err="1">
-                <a:solidFill>
-                  <a:schemeClr val="bg1">
-                    <a:lumMod val="50000"/>
-                  </a:schemeClr>
-                </a:solidFill>
-              </a:rPr>
-              <a:t>copy</a:t>
-            </a:r>
-            <a:r>
-              <a:rPr lang="da-DK" dirty="0">
-                <a:solidFill>
-                  <a:schemeClr val="bg1">
-                    <a:lumMod val="50000"/>
-                  </a:schemeClr>
-                </a:solidFill>
-              </a:rPr>
-              <a:t> </a:t>
-            </a:r>
-            <a:r>
-              <a:rPr lang="da-DK" dirty="0" err="1">
-                <a:solidFill>
-                  <a:schemeClr val="bg1">
-                    <a:lumMod val="50000"/>
-                  </a:schemeClr>
-                </a:solidFill>
-              </a:rPr>
-              <a:t>this</a:t>
-            </a:r>
-            <a:r>
-              <a:rPr lang="da-DK" dirty="0">
-                <a:solidFill>
-                  <a:schemeClr val="bg1">
-                    <a:lumMod val="50000"/>
-                  </a:schemeClr>
-                </a:solidFill>
-              </a:rPr>
-              <a:t> </a:t>
-            </a:r>
-            <a:r>
-              <a:rPr lang="da-DK" dirty="0" err="1">
-                <a:solidFill>
-                  <a:schemeClr val="bg1">
-                    <a:lumMod val="50000"/>
-                  </a:schemeClr>
-                </a:solidFill>
-              </a:rPr>
-              <a:t>code</a:t>
-            </a:r>
-            <a:r>
-              <a:rPr lang="da-DK" dirty="0">
-                <a:solidFill>
-                  <a:schemeClr val="bg1">
-                    <a:lumMod val="50000"/>
-                  </a:schemeClr>
-                </a:solidFill>
-              </a:rPr>
-              <a:t> for </a:t>
-            </a:r>
-            <a:r>
-              <a:rPr lang="da-DK" dirty="0" err="1">
-                <a:solidFill>
-                  <a:schemeClr val="bg1">
-                    <a:lumMod val="50000"/>
-                  </a:schemeClr>
-                </a:solidFill>
-              </a:rPr>
-              <a:t>your</a:t>
-            </a:r>
-            <a:r>
-              <a:rPr lang="da-DK" dirty="0">
-                <a:solidFill>
-                  <a:schemeClr val="bg1">
-                    <a:lumMod val="50000"/>
-                  </a:schemeClr>
-                </a:solidFill>
-              </a:rPr>
-              <a:t> </a:t>
-            </a:r>
-            <a:r>
-              <a:rPr lang="da-DK" dirty="0" err="1">
+              <a:t> Do not copy this code for your </a:t>
+            </a:r>
+            <a:r>
+              <a:rPr lang="en-US" noProof="0" dirty="0" err="1">
                 <a:solidFill>
                   <a:schemeClr val="bg1">
                     <a:lumMod val="50000"/>
@@ -14914,122 +15008,15 @@
               <a:t>handin</a:t>
             </a:r>
             <a:r>
-              <a:rPr lang="da-DK" dirty="0">
+              <a:rPr lang="en-US" noProof="0" dirty="0">
                 <a:solidFill>
                   <a:schemeClr val="bg1">
                     <a:lumMod val="50000"/>
                   </a:schemeClr>
                 </a:solidFill>
               </a:rPr>
-              <a:t> –  </a:t>
-            </a:r>
-            <a:r>
-              <a:rPr lang="da-DK" dirty="0" err="1">
-                <a:solidFill>
-                  <a:schemeClr val="bg1">
-                    <a:lumMod val="50000"/>
-                  </a:schemeClr>
-                </a:solidFill>
-              </a:rPr>
-              <a:t>write</a:t>
-            </a:r>
-            <a:r>
-              <a:rPr lang="da-DK" dirty="0">
-                <a:solidFill>
-                  <a:schemeClr val="bg1">
-                    <a:lumMod val="50000"/>
-                  </a:schemeClr>
-                </a:solidFill>
-              </a:rPr>
-              <a:t> </a:t>
-            </a:r>
-            <a:r>
-              <a:rPr lang="da-DK" dirty="0" err="1">
-                <a:solidFill>
-                  <a:schemeClr val="bg1">
-                    <a:lumMod val="50000"/>
-                  </a:schemeClr>
-                </a:solidFill>
-              </a:rPr>
-              <a:t>your</a:t>
-            </a:r>
-            <a:r>
-              <a:rPr lang="da-DK" dirty="0">
-                <a:solidFill>
-                  <a:schemeClr val="bg1">
-                    <a:lumMod val="50000"/>
-                  </a:schemeClr>
-                </a:solidFill>
-              </a:rPr>
-              <a:t> </a:t>
-            </a:r>
-            <a:r>
-              <a:rPr lang="da-DK" dirty="0" err="1">
-                <a:solidFill>
-                  <a:schemeClr val="bg1">
-                    <a:lumMod val="50000"/>
-                  </a:schemeClr>
-                </a:solidFill>
-              </a:rPr>
-              <a:t>own</a:t>
-            </a:r>
-            <a:r>
-              <a:rPr lang="da-DK" dirty="0">
-                <a:solidFill>
-                  <a:schemeClr val="bg1">
-                    <a:lumMod val="50000"/>
-                  </a:schemeClr>
-                </a:solidFill>
-              </a:rPr>
-              <a:t> </a:t>
-            </a:r>
-            <a:r>
-              <a:rPr lang="da-DK" dirty="0" err="1">
-                <a:solidFill>
-                  <a:schemeClr val="bg1">
-                    <a:lumMod val="50000"/>
-                  </a:schemeClr>
-                </a:solidFill>
-              </a:rPr>
-              <a:t>code</a:t>
-            </a:r>
-            <a:r>
-              <a:rPr lang="da-DK" dirty="0">
-                <a:solidFill>
-                  <a:schemeClr val="bg1">
-                    <a:lumMod val="50000"/>
-                  </a:schemeClr>
-                </a:solidFill>
-              </a:rPr>
-              <a:t> </a:t>
-            </a:r>
-            <a:r>
-              <a:rPr lang="da-DK" dirty="0" err="1">
-                <a:solidFill>
-                  <a:schemeClr val="bg1">
-                    <a:lumMod val="50000"/>
-                  </a:schemeClr>
-                </a:solidFill>
-              </a:rPr>
-              <a:t>following</a:t>
-            </a:r>
-            <a:r>
-              <a:rPr lang="da-DK" dirty="0">
-                <a:solidFill>
-                  <a:schemeClr val="bg1">
-                    <a:lumMod val="50000"/>
-                  </a:schemeClr>
-                </a:solidFill>
-              </a:rPr>
-              <a:t> the steps in the problem statement</a:t>
-            </a:r>
-            <a:endParaRPr lang="en-US" dirty="0">
-              <a:solidFill>
-                <a:schemeClr val="bg1">
-                  <a:lumMod val="50000"/>
-                </a:schemeClr>
-              </a:solidFill>
-            </a:endParaRPr>
+              <a:t> –  write your own code following the steps in the problem statement</a:t>
+            </a:r>
           </a:p>
         </p:txBody>
       </p:sp>

</xml_diff>